<commit_message>
Full-mode results, report, deck and benchmark fixes
</commit_message>
<xml_diff>
--- a/docs/pitch_deck/IBM_Z_Datathon_2026_Pitch_Deck.pptx
+++ b/docs/pitch_deck/IBM_Z_Datathon_2026_Pitch_Deck.pptx
@@ -581,7 +581,7 @@
           <a:lstStyle/>
           <a:p>
             <a:r>
-              <a:t>Three achievements: no false failures from missing documentation, earlier warnings with fewer false alerts, and an end-to-end system on LinuxONE. Close on the limits: synthetic data, weak labels, small fast-mode sample. The repository has the notebook, tests and instructions to reproduce everything.</a:t>
+              <a:t>Three achievements: no false failures from missing documentation, earlier warnings with fewer false alerts, and an end-to-end system on LinuxONE. Close on the limits: synthetic data, weak labels, simulated outcomes. The repository has the notebook, tests and instructions to reproduce everything.</a:t>
             </a:r>
           </a:p>
         </p:txBody>
@@ -651,7 +651,7 @@
           <a:lstStyle/>
           <a:p>
             <a:r>
-              <a:t>Three facts make follow-up tracking hard: obligations are in free text, they depend on each other, and documentation lags behind what actually happened. Naive tools treat 'no record' as 'failed'. In our injected test, 53 of 53 tasks that were done but undocumented were flagged overdue by the naive rule; MedRelay confirmed none and flagged them as unverified. Simulated data.</a:t>
+              <a:t>Three facts make follow-up tracking hard: obligations are in free text, they depend on each other, and documentation lags behind what actually happened. Naive tools treat 'no record' as 'failed'. In our injected test, 716 of 716 tasks that were done but undocumented were flagged overdue by the naive rule; MedRelay confirmed none and flagged them as unverified. Simulated data.</a:t>
             </a:r>
           </a:p>
         </p:txBody>
@@ -1001,7 +1001,7 @@
           <a:lstStyle/>
           <a:p>
             <a:r>
-              <a:t>Only measured results. The strongest finding is behavioural: the evidence-aware engine does not call undocumented work failed, and the graph model warns earlier with fewer false alerts at 24 hours of lead. We also show where we are not better: graph versus independent ML is within noise here, and a deadline-only rule is strong near the deadline. Fast-mode sample is small; full-mode confidence intervals will be tighter.</a:t>
+              <a:t>Only measured results. The strongest finding is behavioural: the evidence-aware engine does not call undocumented work failed, and the graph model warns earlier (72 h median lead) with fewer false alerts than a deadline-only rule. We also show where we are not better: a simple 24-hour reminder matches the graph model on false alerts and has higher recall, and over the whole window a deadline-only rule matches the ML models. The graph model's advantage is lead time and early-window ranking.</a:t>
             </a:r>
           </a:p>
         </p:txBody>
@@ -7252,7 +7252,7 @@
                 </a:solidFill>
                 <a:latin typeface="Arial"/>
               </a:rPr>
-              <a:t>0 / 53</a:t>
+              <a:t>0 / 716</a:t>
             </a:r>
           </a:p>
         </p:txBody>
@@ -7467,7 +7467,7 @@
                 </a:solidFill>
                 <a:latin typeface="Arial"/>
               </a:rPr>
-              <a:t>6.7%</a:t>
+              <a:t>11.3%</a:t>
             </a:r>
           </a:p>
         </p:txBody>
@@ -7545,7 +7545,7 @@
                 </a:solidFill>
                 <a:latin typeface="Arial"/>
               </a:rPr>
-              <a:t>Graph forecasting warns 72 h ahead with fewer false alerts than a deadline-only rule (19.1%).</a:t>
+              <a:t>Graph forecasting warns 72 h ahead with fewer false alerts than a deadline-only rule (18.8%).</a:t>
             </a:r>
           </a:p>
         </p:txBody>
@@ -8096,7 +8096,7 @@
                 </a:solidFill>
                 <a:latin typeface="Arial"/>
               </a:rPr>
-              <a:t>Run the full-size experiments and neural components on the NNPA.</a:t>
+              <a:t>Add neural components that can use the NNPA, and test at larger scale.</a:t>
             </a:r>
           </a:p>
         </p:txBody>
@@ -9612,7 +9612,7 @@
                 </a:solidFill>
                 <a:latin typeface="Arial"/>
               </a:rPr>
-              <a:t>53 / 53</a:t>
+              <a:t>716 / 716</a:t>
             </a:r>
           </a:p>
         </p:txBody>
@@ -9690,7 +9690,7 @@
                 </a:solidFill>
                 <a:latin typeface="Arial"/>
               </a:rPr>
-              <a:t>0 / 53</a:t>
+              <a:t>0 / 716</a:t>
             </a:r>
           </a:p>
         </p:txBody>
@@ -13053,7 +13053,7 @@
                 </a:solidFill>
                 <a:latin typeface="Arial"/>
               </a:rPr>
-              <a:t>49 features, XGBoost, calibrated probability</a:t>
+              <a:t>49 features, random forest, calibrated probability</a:t>
             </a:r>
           </a:p>
         </p:txBody>
@@ -17265,7 +17265,7 @@
                 </a:solidFill>
                 <a:latin typeface="Arial"/>
               </a:rPr>
-              <a:t>XGBoost + calibration</a:t>
+              <a:t>Random forest + calibration</a:t>
             </a:r>
           </a:p>
         </p:txBody>
@@ -17304,7 +17304,7 @@
                 </a:solidFill>
                 <a:latin typeface="Arial"/>
               </a:rPr>
-              <a:t>train, validation and test split by patient; calibrated probabilities</a:t>
+              <a:t>4 model families compared on validation; split by patient; calibrated probabilities</a:t>
             </a:r>
           </a:p>
         </p:txBody>
@@ -18521,7 +18521,7 @@
                 </a:solidFill>
                 <a:latin typeface="Arial"/>
               </a:rPr>
-              <a:t>2 vCPU, 4.2 GB RAM</a:t>
+              <a:t>2 vCPU, 4.2 GB RAM (about 2.6 GB usable)</a:t>
             </a:r>
           </a:p>
         </p:txBody>
@@ -18638,7 +18638,7 @@
                 </a:solidFill>
                 <a:latin typeface="Arial"/>
               </a:rPr>
-              <a:t>Native stack</a:t>
+              <a:t>Engine memory</a:t>
             </a:r>
           </a:p>
         </p:txBody>
@@ -18677,7 +18677,7 @@
                 </a:solidFill>
                 <a:latin typeface="Arial"/>
               </a:rPr>
-              <a:t>native Python 3.12 environment; no container runtime</a:t>
+              <a:t>peak 753 MB at 100,000 events (ML run)</a:t>
             </a:r>
           </a:p>
         </p:txBody>
@@ -18833,7 +18833,7 @@
                 </a:solidFill>
                 <a:latin typeface="Arial"/>
               </a:rPr>
-              <a:t>granite-4.0-350m-Q8_0, 9.2 tokens/s</a:t>
+              <a:t>granite-4.0-350m-Q8_0, 15.0 tokens/s</a:t>
             </a:r>
           </a:p>
         </p:txBody>
@@ -19033,7 +19033,7 @@
                 </a:solidFill>
                 <a:latin typeface="Arial"/>
               </a:rPr>
-              <a:t>357x faster than NumPy BLAS on this VM incl. data conversion; max error 0.045 on values up to 13.2 (16-bit arithmetic).</a:t>
+              <a:t>339x faster than NumPy BLAS on this VM incl. data conversion; max error 0.045 on values up to 13.2 (16-bit arithmetic).</a:t>
             </a:r>
           </a:p>
         </p:txBody>
@@ -19124,7 +19124,7 @@
                 </a:solidFill>
                 <a:latin typeface="Arial"/>
               </a:rPr>
-              <a:t>19.3 k</a:t>
+              <a:t>20.6 k</a:t>
             </a:r>
           </a:p>
         </p:txBody>
@@ -19202,7 +19202,7 @@
                 </a:solidFill>
                 <a:latin typeface="Arial"/>
               </a:rPr>
-              <a:t>graph + state engine, in-memory</a:t>
+              <a:t>graph + state engine (12.4 k at 100,000 events)</a:t>
             </a:r>
           </a:p>
         </p:txBody>
@@ -19293,7 +19293,7 @@
                 </a:solidFill>
                 <a:latin typeface="Arial"/>
               </a:rPr>
-              <a:t>354 to 470</a:t>
+              <a:t>88 to 122</a:t>
             </a:r>
           </a:p>
         </p:txBody>
@@ -19371,7 +19371,7 @@
                 </a:solidFill>
                 <a:latin typeface="Arial"/>
               </a:rPr>
-              <a:t>states + alerts + ML risk, SQLite WAL / in-memory</a:t>
+              <a:t>states + alerts + ML risk (random forest), 1,000 to 100,000 events</a:t>
             </a:r>
           </a:p>
         </p:txBody>
@@ -19462,7 +19462,7 @@
                 </a:solidFill>
                 <a:latin typeface="Arial"/>
               </a:rPr>
-              <a:t>664 ms</a:t>
+              <a:t>2.8 s</a:t>
             </a:r>
           </a:p>
         </p:txBody>
@@ -19540,7 +19540,7 @@
                 </a:solidFill>
                 <a:latin typeface="Arial"/>
               </a:rPr>
-              <a:t>at 2x measured capacity, backpressure, 0 lost</a:t>
+              <a:t>at 2x measured capacity, backpressure, 0 events lost</a:t>
             </a:r>
           </a:p>
         </p:txBody>
@@ -19631,7 +19631,7 @@
                 </a:solidFill>
                 <a:latin typeface="Arial"/>
               </a:rPr>
-              <a:t>38% / 65%</a:t>
+              <a:t>39% / 67%</a:t>
             </a:r>
           </a:p>
         </p:txBody>
@@ -19812,7 +19812,7 @@
                 </a:solidFill>
                 <a:latin typeface="Arial"/>
               </a:rPr>
-              <a:t>the tree and linear risk models run on the CPU, not on the NNPA; only the zDNN microbenchmark proves NNPA execution. Throughput was measured on a small 2 vCPU VM and varies run to run. No security, cost or availability claims are made.</a:t>
+              <a:t>the tree and linear risk models run on the CPU, not on the NNPA; only the zDNN microbenchmark proves NNPA execution. Throughput was measured on a small 2 vCPU VM; ML scoring speed depends on the model chosen on validation. No security, cost or availability claims are made.</a:t>
             </a:r>
           </a:p>
           <a:p>
@@ -20347,8 +20347,8 @@
         </p:blipFill>
         <p:spPr>
           <a:xfrm>
-            <a:off x="612025" y="1778000"/>
-            <a:ext cx="3411451" cy="2260600"/>
+            <a:off x="700252" y="1778000"/>
+            <a:ext cx="3234997" cy="2260600"/>
           </a:xfrm>
           <a:prstGeom prst="rect">
             <a:avLst/>
@@ -20389,7 +20389,7 @@
                 </a:solidFill>
                 <a:latin typeface="Arial"/>
               </a:rPr>
-              <a:t>Graph model C raised 108 alerts at 87% precision, with a 72 h median lead. Deadline-only A reaches 100% recall but alerts on 167 of 283 tasks.</a:t>
+              <a:t>Graph model C: 1,916 alerts, 82% precision, 72 h median lead. A 24 h reminder is similar on false alerts (12.0%) with only 24 h lead; deadline-only A reaches 96% recall but alerts on 2,469 of 3,967 tasks.</a:t>
             </a:r>
           </a:p>
         </p:txBody>
@@ -20543,7 +20543,7 @@
                 </a:solidFill>
                 <a:latin typeface="Arial"/>
               </a:rPr>
-              <a:t>State accuracy at the assessment time 0.903 vs 0.884; 0.997 once late evidence reconciles. The naive rule never recognises an unverified task.</a:t>
+              <a:t>State accuracy at the assessment time 0.911 vs 0.853; 1.000 once late evidence reconciles. The naive rule never recognises an unverified task.</a:t>
             </a:r>
           </a:p>
         </p:txBody>
@@ -20697,7 +20697,7 @@
                 </a:solidFill>
                 <a:latin typeface="Arial"/>
               </a:rPr>
-              <a:t>Temporal features carry the signal; dependency features add a small, significant gain. Evidence features and the graph-vs-independent gap are not significant at this sample size.</a:t>
+              <a:t>Temporal features carry most of the signal (-0.124 PR-AUC when removed). Graph features add a smaller, significant gain (+0.043 over independent tasks). Evidence features add nothing measurable.</a:t>
             </a:r>
           </a:p>
         </p:txBody>
@@ -20786,7 +20786,7 @@
                 </a:solidFill>
                 <a:latin typeface="Arial"/>
               </a:rPr>
-              <a:t>0.830</a:t>
+              <a:t>0.893</a:t>
             </a:r>
           </a:p>
         </p:txBody>
@@ -20864,7 +20864,7 @@
                 </a:solidFill>
                 <a:latin typeface="Arial"/>
               </a:rPr>
-              <a:t>95% CI 0.778 to 0.889; simulated outcomes</a:t>
+              <a:t>95% CI 0.882 to 0.904; simulated outcomes</a:t>
             </a:r>
           </a:p>
         </p:txBody>
@@ -20953,7 +20953,7 @@
                 </a:solidFill>
                 <a:latin typeface="Arial"/>
               </a:rPr>
-              <a:t>0.354</a:t>
+              <a:t>0.358</a:t>
             </a:r>
           </a:p>
         </p:txBody>
@@ -21031,7 +21031,7 @@
                 </a:solidFill>
                 <a:latin typeface="Arial"/>
               </a:rPr>
-              <a:t>vs 0.201 base rate; secondary proof of concept</a:t>
+              <a:t>vs 0.203 base rate; secondary proof of concept</a:t>
             </a:r>
           </a:p>
         </p:txBody>
@@ -21120,7 +21120,7 @@
                 </a:solidFill>
                 <a:latin typeface="Arial"/>
               </a:rPr>
-              <a:t>+0.006</a:t>
+              <a:t>+0.043</a:t>
             </a:r>
           </a:p>
         </p:txBody>
@@ -21198,7 +21198,7 @@
                 </a:solidFill>
                 <a:latin typeface="Arial"/>
               </a:rPr>
-              <a:t>PR-AUC, 95% CI -0.015 to +0.027: not significant</a:t>
+              <a:t>dense-test PR-AUC, 95% CI +0.039 to +0.049; at alert level not significant (-0.001)</a:t>
             </a:r>
           </a:p>
         </p:txBody>
@@ -21287,7 +21287,7 @@
                 </a:solidFill>
                 <a:latin typeface="Arial"/>
               </a:rPr>
-              <a:t>0.71</a:t>
+              <a:t>0.67</a:t>
             </a:r>
           </a:p>
         </p:txBody>
@@ -21365,7 +21365,7 @@
                 </a:solidFill>
                 <a:latin typeface="Arial"/>
               </a:rPr>
-              <a:t>vs 0.59 rules only; 17 failures, 24 episodes</a:t>
+              <a:t>vs 0.57 rules only; 67 failures, 120 episodes</a:t>
             </a:r>
           </a:p>
         </p:txBody>
@@ -21404,7 +21404,7 @@
                 </a:solidFill>
                 <a:latin typeface="Arial"/>
               </a:rPr>
-              <a:t>Fast-mode run on the VM: 60 test patients, 319 test obligations, simulated outcomes, patient-grouped bootstrap (100 resamples), thresholds chosen on validation. Close to the deadline a deadline-only rule is hard to beat (max-score PR-AUC 0.981 vs 0.969).</a:t>
+              <a:t>Full-mode run on the VM (4 h 11 min): 812 test patients, 4,605 test obligations, simulated outcomes, patient-grouped bootstrap (300 resamples), thresholds chosen on validation. Over the whole window the deadline-only rule matches the ML models (max-score PR-AUC 0.963 vs 0.964); the graph model's edge is earlier: PR-AUC 0.74 vs 0.58 at 72 h ahead.</a:t>
             </a:r>
           </a:p>
         </p:txBody>
@@ -24090,7 +24090,7 @@
                 </a:solidFill>
                 <a:latin typeface="Arial"/>
               </a:rPr>
-              <a:t>MEASURED (FAST-MODE RUN ON LINUXONE)</a:t>
+              <a:t>MEASURED (FULL-MODE RUN ON LINUXONE)</a:t>
             </a:r>
           </a:p>
         </p:txBody>
@@ -24129,7 +24129,7 @@
                 </a:solidFill>
                 <a:latin typeface="Arial"/>
               </a:rPr>
-              <a:t>0 of 53</a:t>
+              <a:t>0 of 716</a:t>
             </a:r>
           </a:p>
         </p:txBody>
@@ -24207,7 +24207,7 @@
                 </a:solidFill>
                 <a:latin typeface="Arial"/>
               </a:rPr>
-              <a:t>406</a:t>
+              <a:t>4,895</a:t>
             </a:r>
           </a:p>
         </p:txBody>
@@ -24353,17 +24353,17 @@
           <a:p>
             <a:pPr algn="l">
               <a:lnSpc>
-                <a:spcPts val="1785"/>
-              </a:lnSpc>
-            </a:pPr>
-            <a:r>
-              <a:rPr sz="1700" b="1">
+                <a:spcPts val="1491"/>
+              </a:lnSpc>
+            </a:pPr>
+            <a:r>
+              <a:rPr sz="1420" b="1">
                 <a:solidFill>
                   <a:srgbClr val="33B1FF"/>
                 </a:solidFill>
                 <a:latin typeface="Arial"/>
               </a:rPr>
-              <a:t>6.7% vs 19.1%</a:t>
+              <a:t>11.3% vs 18.8%</a:t>
             </a:r>
           </a:p>
         </p:txBody>
@@ -24480,7 +24480,7 @@
                 </a:solidFill>
                 <a:latin typeface="Arial"/>
               </a:rPr>
-              <a:t>notebook code cells executed without error in a clean kernel</a:t>
+              <a:t>notebook code cells executed without error in a clean kernel (4 h 11 min)</a:t>
             </a:r>
           </a:p>
         </p:txBody>

</xml_diff>